<commit_message>
fix(session-1): align Session 2 preview slide with canonical PRP definition
Slide 26 previewed Session 2 with stale terms — "PRP (Prompt-Reusable
Patterns)" and "INITIAL.md as project bootstrap" — that don't match how
Session 2 actually teaches them. Updated SLIDES.md, SCRIPT.md, and
patched the PPTX in place to use:

- "INITIAL.md — structured feature requests the AI can actually execute"
- "PRPs (Product Requirements Prompts) — implementation blueprints
  with validation gates"

Now matches Session 2 Slides 9 and 11.

Co-Authored-By: Claude Opus 4.7 (1M context) <noreply@anthropic.com>
</commit_message>
<xml_diff>
--- a/slides/session-1-fundamentals.pptx
+++ b/slides/session-1-fundamentals.pptx
@@ -18067,7 +18067,7 @@
               </a:defRPr>
             </a:pPr>
             <a:r>
-              <a:t>INITIAL.md — project bootstrap instructions</a:t>
+              <a:t>INITIAL.md — structured feature requests the AI can actually execute</a:t>
             </a:r>
           </a:p>
         </p:txBody>
@@ -18146,7 +18146,7 @@
               </a:defRPr>
             </a:pPr>
             <a:r>
-              <a:t>PRP (Prompt-Reusable Patterns) — reusable context documents</a:t>
+              <a:t>PRPs (Product Requirements Prompts) — implementation blueprints with validation gates</a:t>
             </a:r>
           </a:p>
         </p:txBody>

</xml_diff>